<commit_message>
Presentation: show PRN instead of Student ID
</commit_message>
<xml_diff>
--- a/presentation/Diabetes_Onset_Prediction_Presentation.pptx
+++ b/presentation/Diabetes_Onset_Prediction_Presentation.pptx
@@ -128,7 +128,7 @@
   <p:extLst>
     <p:ext uri="{521415D9-36F7-43E2-AB2F-B90AF26B5E84}">
       <p14:sectionLst xmlns:p14="http://schemas.microsoft.com/office/powerpoint/2010/main">
-        <p14:section name="Introduction" id="{8dcc61c2-748d-f23c-f533-1f6eda581060}">
+        <p14:section name="Introduction" id="{0b9e93fd-6a84-f1af-a13d-c43591140347}">
           <p14:sldIdLst>
             <p14:sldId id="256"/>
             <p14:sldId id="257"/>
@@ -136,7 +136,7 @@
             <p14:sldId id="259"/>
           </p14:sldIdLst>
         </p14:section>
-        <p14:section name="Data &amp; Method" id="{f234714a-b46d-6244-798e-d2786d211d3a}">
+        <p14:section name="Data &amp; Method" id="{412a61a3-0816-771a-ea9f-b9d77036d7a7}">
           <p14:sldIdLst>
             <p14:sldId id="260"/>
             <p14:sldId id="261"/>
@@ -146,19 +146,19 @@
             <p14:sldId id="265"/>
           </p14:sldIdLst>
         </p14:section>
-        <p14:section name="Results" id="{e3cfc29f-a98d-2839-378b-45af38ee4f9a}">
+        <p14:section name="Results" id="{1a4a327c-c6cc-9325-dff3-41c07d9f9530}">
           <p14:sldIdLst>
             <p14:sldId id="266"/>
             <p14:sldId id="267"/>
             <p14:sldId id="268"/>
           </p14:sldIdLst>
         </p14:section>
-        <p14:section name="Conclusion" id="{8d5fd458-1bd6-63d9-e921-4fbb9ae7874c}">
+        <p14:section name="Conclusion" id="{03825a6f-278b-424c-8a10-e98e335eeedd}">
           <p14:sldIdLst>
             <p14:sldId id="269"/>
           </p14:sldIdLst>
         </p14:section>
-        <p14:section name="Appendix: Model Explorer" id="{84a470bd-4615-bf86-aae8-874da77fb0c2}">
+        <p14:section name="Appendix: Model Explorer" id="{549b3962-f010-fe35-ba47-fd092c906ba6}">
           <p14:sldIdLst>
             <p14:sldId id="270"/>
             <p14:sldId id="271"/>
@@ -167,7 +167,7 @@
             <p14:sldId id="274"/>
           </p14:sldIdLst>
         </p14:section>
-        <p14:section name="Appendix: Details" id="{9f791b03-624e-e331-5dcb-6b772175ec93}">
+        <p14:section name="Appendix: Details" id="{c13583dd-4ee0-d0c7-a6cf-19183caa80ac}">
           <p14:sldIdLst>
             <p14:sldId id="275"/>
             <p14:sldId id="276"/>
@@ -4397,7 +4397,7 @@
                   <a:schemeClr val="accent5"/>
                 </a:solidFill>
               </a:rPr>
-              <a:t>Diabetes Onset Prediction  |  Hardik Jain (23070521056)</a:t>
+              <a:t>Diabetes Onset Prediction  |  Hardik Jain (PRN 23070521056)</a:t>
             </a:r>
             <a:endParaRPr lang="en-US" sz="1000" dirty="0"/>
           </a:p>
@@ -5051,7 +5051,7 @@
                   <a:schemeClr val="bg1"/>
                 </a:solidFill>
               </a:rPr>
-              <a:t>Student ID 23070521056  |  Predictive Analytics (CA-3)</a:t>
+              <a:t>PRN 23070521056  |  Predictive Analytics (CA-3)</a:t>
             </a:r>
             <a:endParaRPr lang="en-US" sz="1600" dirty="0"/>
           </a:p>

</xml_diff>

<commit_message>
Presentation: format PRN as 'PRN: 23070521056'
</commit_message>
<xml_diff>
--- a/presentation/Diabetes_Onset_Prediction_Presentation.pptx
+++ b/presentation/Diabetes_Onset_Prediction_Presentation.pptx
@@ -128,7 +128,7 @@
   <p:extLst>
     <p:ext uri="{521415D9-36F7-43E2-AB2F-B90AF26B5E84}">
       <p14:sectionLst xmlns:p14="http://schemas.microsoft.com/office/powerpoint/2010/main">
-        <p14:section name="Introduction" id="{0b9e93fd-6a84-f1af-a13d-c43591140347}">
+        <p14:section name="Introduction" id="{76dbb74b-9a56-f3e5-ac5d-29f500ef1c22}">
           <p14:sldIdLst>
             <p14:sldId id="256"/>
             <p14:sldId id="257"/>
@@ -136,7 +136,7 @@
             <p14:sldId id="259"/>
           </p14:sldIdLst>
         </p14:section>
-        <p14:section name="Data &amp; Method" id="{412a61a3-0816-771a-ea9f-b9d77036d7a7}">
+        <p14:section name="Data &amp; Method" id="{f3322825-6783-715e-1284-e97fcb9aedb3}">
           <p14:sldIdLst>
             <p14:sldId id="260"/>
             <p14:sldId id="261"/>
@@ -146,19 +146,19 @@
             <p14:sldId id="265"/>
           </p14:sldIdLst>
         </p14:section>
-        <p14:section name="Results" id="{1a4a327c-c6cc-9325-dff3-41c07d9f9530}">
+        <p14:section name="Results" id="{615ba2ce-e4d1-8eeb-be8c-e638c89a54d1}">
           <p14:sldIdLst>
             <p14:sldId id="266"/>
             <p14:sldId id="267"/>
             <p14:sldId id="268"/>
           </p14:sldIdLst>
         </p14:section>
-        <p14:section name="Conclusion" id="{03825a6f-278b-424c-8a10-e98e335eeedd}">
+        <p14:section name="Conclusion" id="{5bce4247-25d8-8ba6-6935-3f8d5f31064e}">
           <p14:sldIdLst>
             <p14:sldId id="269"/>
           </p14:sldIdLst>
         </p14:section>
-        <p14:section name="Appendix: Model Explorer" id="{549b3962-f010-fe35-ba47-fd092c906ba6}">
+        <p14:section name="Appendix: Model Explorer" id="{4f47926e-d778-c875-589c-8ff640be98c8}">
           <p14:sldIdLst>
             <p14:sldId id="270"/>
             <p14:sldId id="271"/>
@@ -167,7 +167,7 @@
             <p14:sldId id="274"/>
           </p14:sldIdLst>
         </p14:section>
-        <p14:section name="Appendix: Details" id="{c13583dd-4ee0-d0c7-a6cf-19183caa80ac}">
+        <p14:section name="Appendix: Details" id="{40afd470-b943-f212-c299-e63926b8300e}">
           <p14:sldIdLst>
             <p14:sldId id="275"/>
             <p14:sldId id="276"/>
@@ -4397,7 +4397,7 @@
                   <a:schemeClr val="accent5"/>
                 </a:solidFill>
               </a:rPr>
-              <a:t>Diabetes Onset Prediction  |  Hardik Jain (PRN 23070521056)</a:t>
+              <a:t>Diabetes Onset Prediction  |  Hardik Jain (PRN: 23070521056)</a:t>
             </a:r>
             <a:endParaRPr lang="en-US" sz="1000" dirty="0"/>
           </a:p>
@@ -5051,7 +5051,7 @@
                   <a:schemeClr val="bg1"/>
                 </a:solidFill>
               </a:rPr>
-              <a:t>PRN 23070521056  |  Predictive Analytics (CA-3)</a:t>
+              <a:t>PRN: 23070521056  |  Predictive Analytics (CA-3)</a:t>
             </a:r>
             <a:endParaRPr lang="en-US" sz="1600" dirty="0"/>
           </a:p>

</xml_diff>